<commit_message>
Update all market data with verified March 2026 figures
Hyperscaler capex: $750B combined 2026E (Amazon $200B, Alphabet $175B,
Microsoft $120B, Meta $125B, Oracle $50B). Semi market: $975B total.
HBM TAM: $38B 2025A, $58B 2026E, SK Hynix 57% share. AI labs: OpenAI
$840B, Anthropic $380B, xAI $230B. Divergence: hardware winners +10-16%
YTD, software losers -12% to -25% YTD. Updated PPTX and all web components.

Co-Authored-By: Claude Opus 4.6 <noreply@anthropic.com>
</commit_message>
<xml_diff>
--- a/AI-Markets-March-2026.pptx
+++ b/AI-Markets-March-2026.pptx
@@ -198,7 +198,7 @@
                     <c:v>2024</c:v>
                   </c:pt>
                   <c:pt idx="2">
-                    <c:v>2025E</c:v>
+                    <c:v>2025</c:v>
                   </c:pt>
                   <c:pt idx="3">
                     <c:v>2026E</c:v>
@@ -223,10 +223,10 @@
                   <c:v>16</c:v>
                 </c:pt>
                 <c:pt idx="2">
-                  <c:v>35</c:v>
+                  <c:v>38</c:v>
                 </c:pt>
                 <c:pt idx="3">
-                  <c:v>55</c:v>
+                  <c:v>58</c:v>
                 </c:pt>
                 <c:pt idx="4">
                   <c:v>100</c:v>
@@ -3548,7 +3548,7 @@
                 <a:ea typeface="Arial Black" pitchFamily="34" charset="-122"/>
                 <a:cs typeface="Arial Black" pitchFamily="34" charset="-120"/>
               </a:rPr>
-              <a:t>~50%</a:t>
+              <a:t>57%</a:t>
             </a:r>
             <a:endParaRPr lang="en-US" sz="3200" dirty="0"/>
           </a:p>
@@ -3626,7 +3626,7 @@
                 <a:ea typeface="Arial Black" pitchFamily="34" charset="-122"/>
                 <a:cs typeface="Arial Black" pitchFamily="34" charset="-120"/>
               </a:rPr>
-              <a:t>~25%</a:t>
+              <a:t>22%</a:t>
             </a:r>
             <a:endParaRPr lang="en-US" sz="3200" dirty="0"/>
           </a:p>
@@ -3704,7 +3704,7 @@
                 <a:ea typeface="Arial Black" pitchFamily="34" charset="-122"/>
                 <a:cs typeface="Arial Black" pitchFamily="34" charset="-120"/>
               </a:rPr>
-              <a:t>~25%</a:t>
+              <a:t>21%</a:t>
             </a:r>
             <a:endParaRPr lang="en-US" sz="3200" dirty="0"/>
           </a:p>
@@ -4240,7 +4240,7 @@
                 <a:ea typeface="Arial Black" pitchFamily="34" charset="-122"/>
                 <a:cs typeface="Arial Black" pitchFamily="34" charset="-120"/>
               </a:rPr>
-              <a:t>~$300B</a:t>
+              <a:t>$840B</a:t>
             </a:r>
             <a:endParaRPr lang="en-US" sz="2800" dirty="0"/>
           </a:p>
@@ -4318,7 +4318,7 @@
                 <a:ea typeface="Arial" pitchFamily="34" charset="-122"/>
                 <a:cs typeface="Arial" pitchFamily="34" charset="-120"/>
               </a:rPr>
-              <a:t>$11.6B ARR (Dec 2025)</a:t>
+              <a:t>$25B ARR (Feb 2026)</a:t>
             </a:r>
             <a:endParaRPr lang="en-US" sz="1200" dirty="0"/>
           </a:p>
@@ -4441,7 +4441,7 @@
                 <a:ea typeface="Arial Black" pitchFamily="34" charset="-122"/>
                 <a:cs typeface="Arial Black" pitchFamily="34" charset="-120"/>
               </a:rPr>
-              <a:t>~$61B</a:t>
+              <a:t>$380B</a:t>
             </a:r>
             <a:endParaRPr lang="en-US" sz="2800" dirty="0"/>
           </a:p>
@@ -4519,7 +4519,7 @@
                 <a:ea typeface="Arial" pitchFamily="34" charset="-122"/>
                 <a:cs typeface="Arial" pitchFamily="34" charset="-120"/>
               </a:rPr>
-              <a:t>$875M ARR, Series E</a:t>
+              <a:t>$19B ARR, $30B round (Feb 2026)</a:t>
             </a:r>
             <a:endParaRPr lang="en-US" sz="1200" dirty="0"/>
           </a:p>
@@ -4642,7 +4642,7 @@
                 <a:ea typeface="Arial Black" pitchFamily="34" charset="-122"/>
                 <a:cs typeface="Arial Black" pitchFamily="34" charset="-120"/>
               </a:rPr>
-              <a:t>~$50B</a:t>
+              <a:t>$230B+</a:t>
             </a:r>
             <a:endParaRPr lang="en-US" sz="2800" dirty="0"/>
           </a:p>
@@ -4720,7 +4720,7 @@
                 <a:ea typeface="Arial" pitchFamily="34" charset="-122"/>
                 <a:cs typeface="Arial" pitchFamily="34" charset="-120"/>
               </a:rPr>
-              <a:t>Elon Musk's AI venture</a:t>
+              <a:t>$20B round (Jan 2026)</a:t>
             </a:r>
             <a:endParaRPr lang="en-US" sz="1200" dirty="0"/>
           </a:p>
@@ -5839,7 +5839,7 @@
                 <a:ea typeface="Arial Black" pitchFamily="34" charset="-122"/>
                 <a:cs typeface="Arial Black" pitchFamily="34" charset="-120"/>
               </a:rPr>
-              <a:t>+62%</a:t>
+              <a:t>+16%</a:t>
             </a:r>
             <a:endParaRPr lang="en-US" sz="1400" dirty="0"/>
           </a:p>
@@ -5917,7 +5917,7 @@
                 <a:ea typeface="Arial Black" pitchFamily="34" charset="-122"/>
                 <a:cs typeface="Arial Black" pitchFamily="34" charset="-120"/>
               </a:rPr>
-              <a:t>+57%</a:t>
+              <a:t>+16%</a:t>
             </a:r>
             <a:endParaRPr lang="en-US" sz="1400" dirty="0"/>
           </a:p>
@@ -5995,7 +5995,7 @@
                 <a:ea typeface="Arial Black" pitchFamily="34" charset="-122"/>
                 <a:cs typeface="Arial Black" pitchFamily="34" charset="-120"/>
               </a:rPr>
-              <a:t>+49%</a:t>
+              <a:t>+12%</a:t>
             </a:r>
             <a:endParaRPr lang="en-US" sz="1400" dirty="0"/>
           </a:p>
@@ -6073,7 +6073,7 @@
                 <a:ea typeface="Arial Black" pitchFamily="34" charset="-122"/>
                 <a:cs typeface="Arial Black" pitchFamily="34" charset="-120"/>
               </a:rPr>
-              <a:t>+20%</a:t>
+              <a:t>+10%</a:t>
             </a:r>
             <a:endParaRPr lang="en-US" sz="1400" dirty="0"/>
           </a:p>
@@ -6272,7 +6272,7 @@
                 <a:ea typeface="Arial Black" pitchFamily="34" charset="-122"/>
                 <a:cs typeface="Arial Black" pitchFamily="34" charset="-120"/>
               </a:rPr>
-              <a:t>-30%</a:t>
+              <a:t>-25%</a:t>
             </a:r>
             <a:endParaRPr lang="en-US" sz="1300" dirty="0"/>
           </a:p>
@@ -6311,7 +6311,7 @@
                 <a:ea typeface="Arial" pitchFamily="34" charset="-122"/>
                 <a:cs typeface="Arial" pitchFamily="34" charset="-120"/>
               </a:rPr>
-              <a:t>Salesforce (CRM)</a:t>
+              <a:t>Adobe (ADBE)</a:t>
             </a:r>
             <a:endParaRPr lang="en-US" sz="1000" dirty="0"/>
           </a:p>
@@ -6350,7 +6350,7 @@
                 <a:ea typeface="Arial Black" pitchFamily="34" charset="-122"/>
                 <a:cs typeface="Arial Black" pitchFamily="34" charset="-120"/>
               </a:rPr>
-              <a:t>-27%</a:t>
+              <a:t>-22%</a:t>
             </a:r>
             <a:endParaRPr lang="en-US" sz="1300" dirty="0"/>
           </a:p>
@@ -6389,7 +6389,7 @@
                 <a:ea typeface="Arial" pitchFamily="34" charset="-122"/>
                 <a:cs typeface="Arial" pitchFamily="34" charset="-120"/>
               </a:rPr>
-              <a:t>Adobe (ADBE)</a:t>
+              <a:t>Shopify (SHOP)</a:t>
             </a:r>
             <a:endParaRPr lang="en-US" sz="1000" dirty="0"/>
           </a:p>
@@ -6428,7 +6428,7 @@
                 <a:ea typeface="Arial Black" pitchFamily="34" charset="-122"/>
                 <a:cs typeface="Arial Black" pitchFamily="34" charset="-120"/>
               </a:rPr>
-              <a:t>-26%</a:t>
+              <a:t>-20%</a:t>
             </a:r>
             <a:endParaRPr lang="en-US" sz="1300" dirty="0"/>
           </a:p>
@@ -6467,7 +6467,7 @@
                 <a:ea typeface="Arial" pitchFamily="34" charset="-122"/>
                 <a:cs typeface="Arial" pitchFamily="34" charset="-120"/>
               </a:rPr>
-              <a:t>Shopify (SHOP)</a:t>
+              <a:t>Salesforce (CRM)</a:t>
             </a:r>
             <a:endParaRPr lang="en-US" sz="1000" dirty="0"/>
           </a:p>
@@ -6506,7 +6506,7 @@
                 <a:ea typeface="Arial Black" pitchFamily="34" charset="-122"/>
                 <a:cs typeface="Arial Black" pitchFamily="34" charset="-120"/>
               </a:rPr>
-              <a:t>-20%</a:t>
+              <a:t>-18%</a:t>
             </a:r>
             <a:endParaRPr lang="en-US" sz="1300" dirty="0"/>
           </a:p>
@@ -6584,7 +6584,7 @@
                 <a:ea typeface="Arial Black" pitchFamily="34" charset="-122"/>
                 <a:cs typeface="Arial Black" pitchFamily="34" charset="-120"/>
               </a:rPr>
-              <a:t>-17%</a:t>
+              <a:t>-15%</a:t>
             </a:r>
             <a:endParaRPr lang="en-US" sz="1300" dirty="0"/>
           </a:p>
@@ -6623,7 +6623,7 @@
                 <a:ea typeface="Arial" pitchFamily="34" charset="-122"/>
                 <a:cs typeface="Arial" pitchFamily="34" charset="-120"/>
               </a:rPr>
-              <a:t>Microsoft (MSFT)</a:t>
+              <a:t>ServiceNow (NOW)</a:t>
             </a:r>
             <a:endParaRPr lang="en-US" sz="1000" dirty="0"/>
           </a:p>
@@ -6662,7 +6662,7 @@
                 <a:ea typeface="Arial Black" pitchFamily="34" charset="-122"/>
                 <a:cs typeface="Arial Black" pitchFamily="34" charset="-120"/>
               </a:rPr>
-              <a:t>-11%</a:t>
+              <a:t>-12%</a:t>
             </a:r>
             <a:endParaRPr lang="en-US" sz="1300" dirty="0"/>
           </a:p>
@@ -6701,7 +6701,7 @@
                 <a:ea typeface="Arial" pitchFamily="34" charset="-122"/>
                 <a:cs typeface="Arial" pitchFamily="34" charset="-120"/>
               </a:rPr>
-              <a:t>ServiceNow (NOW)</a:t>
+              <a:t>Microsoft (MSFT)</a:t>
             </a:r>
             <a:endParaRPr lang="en-US" sz="1000" dirty="0"/>
           </a:p>
@@ -15306,7 +15306,7 @@
                 <a:ea typeface="Arial" pitchFamily="34" charset="-122"/>
                 <a:cs typeface="Arial" pitchFamily="34" charset="-120"/>
               </a:rPr>
-              <a:t>$325B+ in 2025 capex. These companies have the cash flows to sustain it.</a:t>
+              <a:t>$750B in combined 2026E capex. These companies have the cash flows to sustain it.</a:t>
             </a:r>
             <a:endParaRPr lang="en-US" sz="1300" dirty="0"/>
           </a:p>
@@ -15969,7 +15969,7 @@
                 <a:ea typeface="Arial" pitchFamily="34" charset="-122"/>
                 <a:cs typeface="Arial" pitchFamily="34" charset="-120"/>
               </a:rPr>
-              <a:t>Amazon, Alphabet, Microsoft, Meta, and Oracle have guided to ~$325B in combined 2025 capex — with 2026 estimates exceeding $400B. Cumulative AI data center investment is on track to exceed $2 trillion by 2030.</a:t>
+              <a:t>Amazon, Alphabet, Microsoft, Meta, and Oracle spent ~$443B in combined 2025 capex — with 2026 estimates approaching $750B. Cumulative AI data center investment is on track to exceed $2 trillion by 2030.</a:t>
             </a:r>
             <a:endParaRPr lang="en-US" sz="1250" dirty="0"/>
           </a:p>
@@ -16081,7 +16081,7 @@
                 <a:ea typeface="Arial" pitchFamily="34" charset="-122"/>
                 <a:cs typeface="Arial" pitchFamily="34" charset="-120"/>
               </a:rPr>
-              <a:t>Semiconductor stocks (SOXX) and software stocks (IGV) are diverging sharply. The same AI wave is creating winners and losers simultaneously.</a:t>
+              <a:t>Semiconductor stocks (SOXX) up ~13% YTD. Software stocks (IGV) down ~20% YTD. A 33-point spread — the same AI wave is creating winners and losers simultaneously.</a:t>
             </a:r>
             <a:endParaRPr lang="en-US" sz="1250" dirty="0"/>
           </a:p>
@@ -20674,7 +20674,7 @@
                 <a:ea typeface="Arial Black" pitchFamily="34" charset="-122"/>
                 <a:cs typeface="Arial Black" pitchFamily="34" charset="-120"/>
               </a:rPr>
-              <a:t>$325B+</a:t>
+              <a:t>$750B</a:t>
             </a:r>
             <a:endParaRPr lang="en-US" sz="4400" dirty="0"/>
           </a:p>
@@ -20713,7 +20713,7 @@
                 <a:ea typeface="Arial" pitchFamily="34" charset="-122"/>
                 <a:cs typeface="Arial" pitchFamily="34" charset="-120"/>
               </a:rPr>
-              <a:t>Combined hyperscaler 2025 capex</a:t>
+              <a:t>Combined hyperscaler 2026E capex</a:t>
             </a:r>
             <a:endParaRPr lang="en-US" sz="1100" dirty="0"/>
           </a:p>
@@ -21296,7 +21296,7 @@
                           <a:ea typeface="Arial" pitchFamily="34" charset="-122"/>
                           <a:cs typeface="Arial" pitchFamily="34" charset="-120"/>
                         </a:rPr>
-                        <a:t>$100B+</a:t>
+                        <a:t>$200B</a:t>
                       </a:r>
                       <a:endParaRPr lang="en-US" sz="900" dirty="0">
                         <a:latin typeface="Arial" charset="0"/>
@@ -21567,7 +21567,7 @@
                           <a:ea typeface="Arial" pitchFamily="34" charset="-122"/>
                           <a:cs typeface="Arial" pitchFamily="34" charset="-120"/>
                         </a:rPr>
-                        <a:t>$75B+</a:t>
+                        <a:t>$175B</a:t>
                       </a:r>
                       <a:endParaRPr lang="en-US" sz="900" dirty="0">
                         <a:latin typeface="Arial" charset="0"/>
@@ -21832,7 +21832,7 @@
                           <a:ea typeface="Arial" pitchFamily="34" charset="-122"/>
                           <a:cs typeface="Arial" pitchFamily="34" charset="-120"/>
                         </a:rPr>
-                        <a:t>$80B+</a:t>
+                        <a:t>$120B</a:t>
                       </a:r>
                       <a:endParaRPr lang="en-US" sz="900" dirty="0">
                         <a:latin typeface="Arial" charset="0"/>
@@ -22103,7 +22103,7 @@
                           <a:ea typeface="Arial" pitchFamily="34" charset="-122"/>
                           <a:cs typeface="Arial" pitchFamily="34" charset="-120"/>
                         </a:rPr>
-                        <a:t>$65B+</a:t>
+                        <a:t>$125B</a:t>
                       </a:r>
                       <a:endParaRPr lang="en-US" sz="900" dirty="0">
                         <a:latin typeface="Arial" charset="0"/>
@@ -22368,7 +22368,7 @@
                           <a:ea typeface="Arial" pitchFamily="34" charset="-122"/>
                           <a:cs typeface="Arial" pitchFamily="34" charset="-120"/>
                         </a:rPr>
-                        <a:t>$25B+</a:t>
+                        <a:t>$50B</a:t>
                       </a:r>
                       <a:endParaRPr lang="en-US" sz="900" dirty="0">
                         <a:latin typeface="Arial" charset="0"/>
@@ -22716,7 +22716,7 @@
                 <a:ea typeface="Arial Black" pitchFamily="34" charset="-122"/>
                 <a:cs typeface="Arial Black" pitchFamily="34" charset="-120"/>
               </a:rPr>
-              <a:t>THE $680B SEMICONDUCTOR MARKET</a:t>
+              <a:t>THE $975B SEMICONDUCTOR MARKET</a:t>
             </a:r>
             <a:endParaRPr lang="en-US" sz="2700" dirty="0"/>
           </a:p>
@@ -22755,7 +22755,7 @@
                 <a:ea typeface="Arial" pitchFamily="34" charset="-122"/>
                 <a:cs typeface="Arial" pitchFamily="34" charset="-120"/>
               </a:rPr>
-              <a:t>Logic + Memory = ~70% of the market — AI's center of gravity.</a:t>
+              <a:t>Logic + Memory = ~70% of the market — AI's center of gravity. WSTS forecasts $975B for 2026.</a:t>
             </a:r>
             <a:endParaRPr lang="en-US" sz="1350" dirty="0"/>
           </a:p>
@@ -22853,7 +22853,7 @@
                 <a:ea typeface="Arial Black" pitchFamily="34" charset="-122"/>
                 <a:cs typeface="Arial Black" pitchFamily="34" charset="-120"/>
               </a:rPr>
-              <a:t>~$270B</a:t>
+              <a:t>~$390B</a:t>
             </a:r>
             <a:endParaRPr lang="en-US" sz="1000" dirty="0"/>
           </a:p>
@@ -22868,7 +22868,7 @@
         <p:spPr>
           <a:xfrm>
             <a:off x="457200" y="1828800"/>
-            <a:ext cx="2560320" cy="274320"/>
+            <a:ext cx="2743200" cy="274320"/>
           </a:xfrm>
           <a:prstGeom prst="rect">
             <a:avLst/>
@@ -22887,7 +22887,7 @@
         </p:nvSpPr>
         <p:spPr>
           <a:xfrm>
-            <a:off x="3154680" y="1828800"/>
+            <a:off x="3337560" y="1828800"/>
             <a:ext cx="4114800" cy="274320"/>
           </a:xfrm>
           <a:prstGeom prst="rect">
@@ -22951,7 +22951,7 @@
                 <a:ea typeface="Arial Black" pitchFamily="34" charset="-122"/>
                 <a:cs typeface="Arial Black" pitchFamily="34" charset="-120"/>
               </a:rPr>
-              <a:t>~$190B</a:t>
+              <a:t>~$290B</a:t>
             </a:r>
             <a:endParaRPr lang="en-US" sz="1000" dirty="0"/>
           </a:p>
@@ -22966,7 +22966,7 @@
         <p:spPr>
           <a:xfrm>
             <a:off x="457200" y="2240280"/>
-            <a:ext cx="1005840" cy="274320"/>
+            <a:ext cx="914400" cy="274320"/>
           </a:xfrm>
           <a:prstGeom prst="rect">
             <a:avLst/>
@@ -22985,7 +22985,7 @@
         </p:nvSpPr>
         <p:spPr>
           <a:xfrm>
-            <a:off x="1600200" y="2240280"/>
+            <a:off x="1508760" y="2240280"/>
             <a:ext cx="4114800" cy="274320"/>
           </a:xfrm>
           <a:prstGeom prst="rect">
@@ -23049,7 +23049,7 @@
                 <a:ea typeface="Arial Black" pitchFamily="34" charset="-122"/>
                 <a:cs typeface="Arial Black" pitchFamily="34" charset="-120"/>
               </a:rPr>
-              <a:t>~$75B</a:t>
+              <a:t>~$95B</a:t>
             </a:r>
             <a:endParaRPr lang="en-US" sz="1000" dirty="0"/>
           </a:p>
@@ -23064,7 +23064,7 @@
         <p:spPr>
           <a:xfrm>
             <a:off x="457200" y="2651760"/>
-            <a:ext cx="640080" cy="274320"/>
+            <a:ext cx="457200" cy="274320"/>
           </a:xfrm>
           <a:prstGeom prst="rect">
             <a:avLst/>
@@ -23083,7 +23083,7 @@
         </p:nvSpPr>
         <p:spPr>
           <a:xfrm>
-            <a:off x="1234440" y="2651760"/>
+            <a:off x="1051560" y="2651760"/>
             <a:ext cx="4114800" cy="274320"/>
           </a:xfrm>
           <a:prstGeom prst="rect">
@@ -23147,7 +23147,7 @@
                 <a:ea typeface="Arial Black" pitchFamily="34" charset="-122"/>
                 <a:cs typeface="Arial Black" pitchFamily="34" charset="-120"/>
               </a:rPr>
-              <a:t>~$45B</a:t>
+              <a:t>~$50B</a:t>
             </a:r>
             <a:endParaRPr lang="en-US" sz="1000" dirty="0"/>
           </a:p>
@@ -23162,7 +23162,7 @@
         <p:spPr>
           <a:xfrm>
             <a:off x="457200" y="3063240"/>
-            <a:ext cx="822960" cy="274320"/>
+            <a:ext cx="731520" cy="274320"/>
           </a:xfrm>
           <a:prstGeom prst="rect">
             <a:avLst/>
@@ -23181,7 +23181,7 @@
         </p:nvSpPr>
         <p:spPr>
           <a:xfrm>
-            <a:off x="1417320" y="3063240"/>
+            <a:off x="1325880" y="3063240"/>
             <a:ext cx="4114800" cy="274320"/>
           </a:xfrm>
           <a:prstGeom prst="rect">
@@ -23245,7 +23245,7 @@
                 <a:ea typeface="Arial Black" pitchFamily="34" charset="-122"/>
                 <a:cs typeface="Arial Black" pitchFamily="34" charset="-120"/>
               </a:rPr>
-              <a:t>~$60B</a:t>
+              <a:t>~$80B</a:t>
             </a:r>
             <a:endParaRPr lang="en-US" sz="1000" dirty="0"/>
           </a:p>
@@ -23260,7 +23260,7 @@
         <p:spPr>
           <a:xfrm>
             <a:off x="457200" y="3474720"/>
-            <a:ext cx="1463040" cy="274320"/>
+            <a:ext cx="1005840" cy="274320"/>
           </a:xfrm>
           <a:prstGeom prst="rect">
             <a:avLst/>
@@ -23279,7 +23279,7 @@
         </p:nvSpPr>
         <p:spPr>
           <a:xfrm>
-            <a:off x="2057400" y="3474720"/>
+            <a:off x="1600200" y="3474720"/>
             <a:ext cx="4114800" cy="274320"/>
           </a:xfrm>
           <a:prstGeom prst="rect">
@@ -23402,7 +23402,7 @@
                 <a:ea typeface="Arial" pitchFamily="34" charset="-122"/>
                 <a:cs typeface="Arial" pitchFamily="34" charset="-120"/>
               </a:rPr>
-              <a:t>Logic + Memory = ~$460B (~68% of total) — AI's center of gravity.</a:t>
+              <a:t>Logic + Memory = ~$680B (~70% of total) — AI's center of gravity.</a:t>
             </a:r>
             <a:endParaRPr lang="en-US" sz="1050" dirty="0"/>
           </a:p>
@@ -23441,7 +23441,7 @@
                 <a:ea typeface="Arial" pitchFamily="34" charset="-122"/>
                 <a:cs typeface="Arial" pitchFamily="34" charset="-120"/>
               </a:rPr>
-              <a:t>Sources: WSTS, SIA, Gartner, SEMI. Figures reflect 2025 estimates; 2026 total market forecast ~$720B.</a:t>
+              <a:t>Sources: WSTS, SIA, Gartner, SEMI. 2025 actual: $796B. 2026 WSTS forecast: $975B.</a:t>
             </a:r>
             <a:endParaRPr lang="en-US" sz="700" dirty="0"/>
           </a:p>

</xml_diff>